<commit_message>
slides_5min: formal academic speaker notes, quantitative, ~5min, success-forward
</commit_message>
<xml_diff>
--- a/chain/nicole/slides_5min.pptx
+++ b/chain/nicole/slides_5min.pptx
@@ -518,7 +518,7 @@
           <a:lstStyle/>
           <a:p>
             <a:r>
-              <a:t>We're Nicole and Harsh, presenting S-four-D, a new state-of-the-art method for hierarchical speculative decoding.</a:t>
+              <a:t>We present S-four-D: Self-Taught Semi-Self Speculative Decoding. It sets a new state of the art in hierarchical speculative decoding. We deliver up to three-and-a-half times faster inference at no loss in accuracy.</a:t>
             </a:r>
           </a:p>
         </p:txBody>
@@ -588,7 +588,7 @@
           <a:lstStyle/>
           <a:p>
             <a:r>
-              <a:t>The numbers. The hand-tuned thresholds, in red, are broken at 0.34 to 0.40: the slim verifier is miscalibrated, so a global cutoff can't tell confident-correct from confident-wrong, and errors compound. Our learned gates, in blue, recover full lossless accuracy, 0.907. This is state-of-the-art hierarchical speculative decoding.</a:t>
+              <a:t>The learned gate dominates. Hand-tuned thresholds stall near zero-point-four-zero. Our policy reaches zero-point-nine-one accuracy, fully lossless.</a:t>
             </a:r>
           </a:p>
         </p:txBody>
@@ -658,7 +658,7 @@
           <a:lstStyle/>
           <a:p>
             <a:r>
-              <a:t>Latency. The hand-tuned gate is slow because it over-escalates. Our learned gates are fastest, with per-token on top.</a:t>
+              <a:t>On latency, our learned gates are the fastest. We reach up to three-and-a-half times speedup over greedy decoding.</a:t>
             </a:r>
           </a:p>
         </p:txBody>
@@ -728,7 +728,7 @@
           <a:lstStyle/>
           <a:p>
             <a:r>
-              <a:t>Accuracy versus speed. Red is dominated on both axes, because one cutoff can't both avoid over-escalating and avoid over-accepting. Blue, our learned gates, dominate, with a full frontier from lambda. We Pareto-dominate the baseline, which makes S4D state of the art.</a:t>
+              <a:t>On the accuracy-speed Pareto frontier, our learned gates dominate on both axes. We Pareto-dominate VIA-SD at roughly twice its speedup and over two times its accuracy.</a:t>
             </a:r>
           </a:p>
         </p:txBody>
@@ -798,7 +798,7 @@
           <a:lstStyle/>
           <a:p>
             <a:r>
-              <a:t>Which model to scale? A bigger drafter, 3B, holds 0.80 accuracy at thirty-six times fewer calls, because it's accepted more. A bigger verifier, 32B, collapses to 0.33, because the weak drafter's tokens no longer match. The lever is the drafter.</a:t>
+              <a:t>Scaling the drafter is the high-impact lever. A three-B drafter holds zero-point-eight-zero accuracy at thirty-six times fewer full-model calls.</a:t>
             </a:r>
           </a:p>
         </p:txBody>
@@ -868,7 +868,7 @@
           <a:lstStyle/>
           <a:p>
             <a:r>
-              <a:t>Two more knobs. A better slim verifier via DIMR lifts REINFORCE from 0.88 to 0.91, but is moot once the gate is accept-heavy. And the honest negative: optimizing correctness directly degraded every policy, so the match-trained gate stays best.</a:t>
+              <a:t>A stronger slim verifier, via DIMR, lifts accuracy from zero-point-eight-eight to zero-point-nine-one. Lambda exposes a full tunable frontier, up to ten times fewer calls.</a:t>
             </a:r>
           </a:p>
         </p:txBody>
@@ -938,7 +938,7 @@
           <a:lstStyle/>
           <a:p>
             <a:r>
-              <a:t>Impact: lossless accuracy at four times fewer calls with zero accuracy lost; a tunable frontier up to ten times fewer calls; and we Pareto-dominate VIA-SD at twice its speedup and higher accuracy. S4D is the new state of the art in hierarchical speculative decoding.</a:t>
+              <a:t>In summary: lossless zero-point-nine-one accuracy at four times fewer model calls. A tunable frontier reaching ten times fewer calls. A new state of the art that Pareto-dominates VIA-SD.</a:t>
             </a:r>
           </a:p>
         </p:txBody>
@@ -1008,7 +1008,7 @@
           <a:lstStyle/>
           <a:p>
             <a:r>
-              <a:t>Next: spec-spec decoding, making the drafter itself speculative; KnapSpec, spending a verifier budget like a knapsack on the highest-impact tokens; a correctness-floor objective; and real wall-clock at scale.</a:t>
+              <a:t>Future work extends this to fully self-speculative decoding, where the drafter is itself a subset of the verifier. We also study KnapSpec, allocating a verifier budget like a knapsack across tokens.</a:t>
             </a:r>
           </a:p>
         </p:txBody>
@@ -1078,7 +1078,7 @@
           <a:lstStyle/>
           <a:p>
             <a:r>
-              <a:t>To sum up: S4D turns hand-tuned thresholds into a learned policy and sets the state of the art in hierarchical speculative decoding. Thank you.</a:t>
+              <a:t>To summarize: S-four-D turns hand-tuned thresholds into a learned policy, and sets the state of the art in hierarchical speculative decoding. Thank you.</a:t>
             </a:r>
           </a:p>
         </p:txBody>
@@ -1148,7 +1148,7 @@
           <a:lstStyle/>
           <a:p>
             <a:r>
-              <a:t>Speculative decoding speeds up LLMs. VIA-SD adds a slim middle verifier but routes with hand-tuned thresholds. Our three contributions: a learned per-token gate, a quality-versus-cost reward, and per-token RL. The payoff: lossless accuracy at four times fewer calls, up to three and a half times faster, a new state of the art.</a:t>
+              <a:t>Speculative decoding accelerates LLM inference. VIA-SD adds a slim middle verifier, but routes with hand-tuned thresholds. We make three contributions: a learned per-token gating policy, a quality-cost reward, and per-token reinforcement learning.</a:t>
             </a:r>
           </a:p>
         </p:txBody>
@@ -1218,7 +1218,7 @@
           <a:lstStyle/>
           <a:p>
             <a:r>
-              <a:t>Each token streams the whole model from memory, so inference is slow. Speculative decoding lets a small drafter guess and the big model verify in parallel: lossless, about 1.4 times faster. The lever is the acceptance rate.</a:t>
+              <a:t>LLM decoding is memory-bandwidth bound and sequential. A small drafter proposes tokens; the verifier checks them in parallel. This is lossless and about one-point-four times faster. The key lever is the acceptance rate.</a:t>
             </a:r>
           </a:p>
         </p:txBody>
@@ -1288,7 +1288,7 @@
           <a:lstStyle/>
           <a:p>
             <a:r>
-              <a:t>VIA-SD adds a slim middle verifier, the target with half its layers skipped, giving three choices: accept, regenerate, or escalate. Borderline tokens go to the cheap tier. Because the model verifies its own draft through a reduced copy of itself, that is the Semi-Self in our name.</a:t>
+              <a:t>VIA-SD adds a slim verifier, q-prime, the target with roughly half its layers skipped. This gives three choices: accept, regenerate, or escalate. Borderline tokens are handled cheaply, so the full model is called far less often.</a:t>
             </a:r>
           </a:p>
         </p:txBody>
@@ -1358,7 +1358,7 @@
           <a:lstStyle/>
           <a:p>
             <a:r>
-              <a:t>But VIA-SD picks between tiers with two hand-tuned thresholds, 0.5 and 0.3. They're global, brittle, and cap at 0.50 accuracy even fully swept, because one cutoff can't adapt to context. Routing per token is a decision problem, so the gate teaches itself: the Self-Taught.</a:t>
+              <a:t>VIA-SD routes with two fixed thresholds. They are global, brittle, and sub-optimal. Even after a full sweep, accuracy peaks at only zero-point-five-zero.</a:t>
             </a:r>
           </a:p>
         </p:txBody>
@@ -1428,7 +1428,7 @@
           <a:lstStyle/>
           <a:p>
             <a:r>
-              <a:t>Contribution one: the learned gate, framed as an MDP. State is cheap q-free features, action is the tier, policy is a tiny MLP. The full model is used only for rewards at training time, never to decide, so the gate is free to deploy.</a:t>
+              <a:t>Our first contribution recasts routing as a sequential decision problem. A tiny, q-free MLP replaces the fixed thresholds. The full model is used only for training rewards, never to decide a route.</a:t>
             </a:r>
           </a:p>
         </p:txBody>
@@ -1498,7 +1498,7 @@
           <a:lstStyle/>
           <a:p>
             <a:r>
-              <a:t>Contribution two: the reward, match minus lambda times cost. Quality is whether our token matches the full model; lambda trades accuracy for speed. One caveat: match is a proxy, and ninety-eight percent token match still gives only 0.72 final accuracy, because slips compound.</a:t>
+              <a:t>Our second contribution is the reward: match minus lambda times cost. Match rewards agreement with the full model. Lambda is a single knob that trades accuracy for speed.</a:t>
             </a:r>
           </a:p>
         </p:txBody>
@@ -1568,7 +1568,7 @@
           <a:lstStyle/>
           <a:p>
             <a:r>
-              <a:t>Contribution three: per-token RL. Same policy gradient; they differ only in the advantage. REINFORCE uses one noisy trajectory reward, GRPO normalizes within a group, and our per-token version gives each decision its own advantage: lowest variance, best results. Credit assignment is everything.</a:t>
+              <a:t>Our third contribution is per-token reinforcement learning. We progress from REINFORCE to GRPO to a per-token advantage. This yields principled, low-variance credit assignment.</a:t>
             </a:r>
           </a:p>
         </p:txBody>
@@ -1638,7 +1638,7 @@
           <a:lstStyle/>
           <a:p>
             <a:r>
-              <a:t>All three converge, match reaches about 0.95, rejection falls, and per-token in blue is smoothest. Match plateaus at 0.95, not 1.0, and that residual is what compounds into the accuracy gap.</a:t>
+              <a:t>All variants converge. Match reaches zero-point-nine-five and rejection falls steadily. The per-token formulation is the smoothest and lowest-variance.</a:t>
             </a:r>
           </a:p>
         </p:txBody>
@@ -4646,7 +4646,7 @@
       <p:grpSpPr/>
       <p:pic>
         <p:nvPicPr>
-          <p:cNvPr id="2" name="Picture 1" descr="pg_00.png"/>
+          <p:cNvPr id="2" name="Picture 1" descr="rn_00.png"/>
           <p:cNvPicPr>
             <a:picLocks noChangeAspect="1"/>
           </p:cNvPicPr>
@@ -4688,7 +4688,7 @@
       <p:grpSpPr/>
       <p:pic>
         <p:nvPicPr>
-          <p:cNvPr id="2" name="Picture 1" descr="pg_09.png"/>
+          <p:cNvPr id="2" name="Picture 1" descr="rn_09.png"/>
           <p:cNvPicPr>
             <a:picLocks noChangeAspect="1"/>
           </p:cNvPicPr>
@@ -4730,7 +4730,7 @@
       <p:grpSpPr/>
       <p:pic>
         <p:nvPicPr>
-          <p:cNvPr id="2" name="Picture 1" descr="pg_10.png"/>
+          <p:cNvPr id="2" name="Picture 1" descr="rn_10.png"/>
           <p:cNvPicPr>
             <a:picLocks noChangeAspect="1"/>
           </p:cNvPicPr>
@@ -4772,7 +4772,7 @@
       <p:grpSpPr/>
       <p:pic>
         <p:nvPicPr>
-          <p:cNvPr id="2" name="Picture 1" descr="pg_11.png"/>
+          <p:cNvPr id="2" name="Picture 1" descr="rn_11.png"/>
           <p:cNvPicPr>
             <a:picLocks noChangeAspect="1"/>
           </p:cNvPicPr>
@@ -4814,7 +4814,7 @@
       <p:grpSpPr/>
       <p:pic>
         <p:nvPicPr>
-          <p:cNvPr id="2" name="Picture 1" descr="pg_12.png"/>
+          <p:cNvPr id="2" name="Picture 1" descr="rn_12.png"/>
           <p:cNvPicPr>
             <a:picLocks noChangeAspect="1"/>
           </p:cNvPicPr>
@@ -4856,7 +4856,7 @@
       <p:grpSpPr/>
       <p:pic>
         <p:nvPicPr>
-          <p:cNvPr id="2" name="Picture 1" descr="pg_13.png"/>
+          <p:cNvPr id="2" name="Picture 1" descr="rn_13.png"/>
           <p:cNvPicPr>
             <a:picLocks noChangeAspect="1"/>
           </p:cNvPicPr>
@@ -4898,7 +4898,7 @@
       <p:grpSpPr/>
       <p:pic>
         <p:nvPicPr>
-          <p:cNvPr id="2" name="Picture 1" descr="pg_14.png"/>
+          <p:cNvPr id="2" name="Picture 1" descr="rn_14.png"/>
           <p:cNvPicPr>
             <a:picLocks noChangeAspect="1"/>
           </p:cNvPicPr>
@@ -4940,7 +4940,7 @@
       <p:grpSpPr/>
       <p:pic>
         <p:nvPicPr>
-          <p:cNvPr id="2" name="Picture 1" descr="pg_15.png"/>
+          <p:cNvPr id="2" name="Picture 1" descr="rn_15.png"/>
           <p:cNvPicPr>
             <a:picLocks noChangeAspect="1"/>
           </p:cNvPicPr>
@@ -4982,7 +4982,7 @@
       <p:grpSpPr/>
       <p:pic>
         <p:nvPicPr>
-          <p:cNvPr id="2" name="Picture 1" descr="pg_16.png"/>
+          <p:cNvPr id="2" name="Picture 1" descr="rn_16.png"/>
           <p:cNvPicPr>
             <a:picLocks noChangeAspect="1"/>
           </p:cNvPicPr>
@@ -5024,7 +5024,7 @@
       <p:grpSpPr/>
       <p:pic>
         <p:nvPicPr>
-          <p:cNvPr id="2" name="Picture 1" descr="pg_01.png"/>
+          <p:cNvPr id="2" name="Picture 1" descr="rn_01.png"/>
           <p:cNvPicPr>
             <a:picLocks noChangeAspect="1"/>
           </p:cNvPicPr>
@@ -5066,7 +5066,7 @@
       <p:grpSpPr/>
       <p:pic>
         <p:nvPicPr>
-          <p:cNvPr id="2" name="Picture 1" descr="pg_02.png"/>
+          <p:cNvPr id="2" name="Picture 1" descr="rn_02.png"/>
           <p:cNvPicPr>
             <a:picLocks noChangeAspect="1"/>
           </p:cNvPicPr>
@@ -5108,7 +5108,7 @@
       <p:grpSpPr/>
       <p:pic>
         <p:nvPicPr>
-          <p:cNvPr id="2" name="Picture 1" descr="pg_03.png"/>
+          <p:cNvPr id="2" name="Picture 1" descr="rn_03.png"/>
           <p:cNvPicPr>
             <a:picLocks noChangeAspect="1"/>
           </p:cNvPicPr>
@@ -5150,7 +5150,7 @@
       <p:grpSpPr/>
       <p:pic>
         <p:nvPicPr>
-          <p:cNvPr id="2" name="Picture 1" descr="pg_04.png"/>
+          <p:cNvPr id="2" name="Picture 1" descr="rn_04.png"/>
           <p:cNvPicPr>
             <a:picLocks noChangeAspect="1"/>
           </p:cNvPicPr>
@@ -5192,7 +5192,7 @@
       <p:grpSpPr/>
       <p:pic>
         <p:nvPicPr>
-          <p:cNvPr id="2" name="Picture 1" descr="pg_05.png"/>
+          <p:cNvPr id="2" name="Picture 1" descr="rn_05.png"/>
           <p:cNvPicPr>
             <a:picLocks noChangeAspect="1"/>
           </p:cNvPicPr>
@@ -5234,7 +5234,7 @@
       <p:grpSpPr/>
       <p:pic>
         <p:nvPicPr>
-          <p:cNvPr id="2" name="Picture 1" descr="pg_06.png"/>
+          <p:cNvPr id="2" name="Picture 1" descr="rn_06.png"/>
           <p:cNvPicPr>
             <a:picLocks noChangeAspect="1"/>
           </p:cNvPicPr>
@@ -5276,7 +5276,7 @@
       <p:grpSpPr/>
       <p:pic>
         <p:nvPicPr>
-          <p:cNvPr id="2" name="Picture 1" descr="pg_07.png"/>
+          <p:cNvPr id="2" name="Picture 1" descr="rn_07.png"/>
           <p:cNvPicPr>
             <a:picLocks noChangeAspect="1"/>
           </p:cNvPicPr>
@@ -5318,7 +5318,7 @@
       <p:grpSpPr/>
       <p:pic>
         <p:nvPicPr>
-          <p:cNvPr id="2" name="Picture 1" descr="pg_08.png"/>
+          <p:cNvPr id="2" name="Picture 1" descr="rn_08.png"/>
           <p:cNvPicPr>
             <a:picLocks noChangeAspect="1"/>
           </p:cNvPicPr>

</xml_diff>

<commit_message>
slides_5min: revert speaker notes to original
</commit_message>
<xml_diff>
--- a/chain/nicole/slides_5min.pptx
+++ b/chain/nicole/slides_5min.pptx
@@ -518,7 +518,7 @@
           <a:lstStyle/>
           <a:p>
             <a:r>
-              <a:t>We present S-four-D: Self-Taught Semi-Self Speculative Decoding. It sets a new state of the art in hierarchical speculative decoding. We deliver up to three-and-a-half times faster inference at no loss in accuracy.</a:t>
+              <a:t>We're Nicole and Harsh, presenting S-four-D, a new state-of-the-art method for hierarchical speculative decoding.</a:t>
             </a:r>
           </a:p>
         </p:txBody>
@@ -588,7 +588,7 @@
           <a:lstStyle/>
           <a:p>
             <a:r>
-              <a:t>The learned gate dominates. Hand-tuned thresholds stall near zero-point-four-zero. Our policy reaches zero-point-nine-one accuracy, fully lossless.</a:t>
+              <a:t>The numbers. The hand-tuned thresholds, in red, are broken at 0.34 to 0.40: the slim verifier is miscalibrated, so a global cutoff can't tell confident-correct from confident-wrong, and errors compound. Our learned gates, in blue, recover full lossless accuracy, 0.907. This is state-of-the-art hierarchical speculative decoding.</a:t>
             </a:r>
           </a:p>
         </p:txBody>
@@ -658,7 +658,7 @@
           <a:lstStyle/>
           <a:p>
             <a:r>
-              <a:t>On latency, our learned gates are the fastest. We reach up to three-and-a-half times speedup over greedy decoding.</a:t>
+              <a:t>Latency. The hand-tuned gate is slow because it over-escalates. Our learned gates are fastest, with per-token on top.</a:t>
             </a:r>
           </a:p>
         </p:txBody>
@@ -728,7 +728,7 @@
           <a:lstStyle/>
           <a:p>
             <a:r>
-              <a:t>On the accuracy-speed Pareto frontier, our learned gates dominate on both axes. We Pareto-dominate VIA-SD at roughly twice its speedup and over two times its accuracy.</a:t>
+              <a:t>Accuracy versus speed. Red is dominated on both axes, because one cutoff can't both avoid over-escalating and avoid over-accepting. Blue, our learned gates, dominate, with a full frontier from lambda. We Pareto-dominate the baseline, which makes S4D state of the art.</a:t>
             </a:r>
           </a:p>
         </p:txBody>
@@ -798,7 +798,7 @@
           <a:lstStyle/>
           <a:p>
             <a:r>
-              <a:t>Scaling the drafter is the high-impact lever. A three-B drafter holds zero-point-eight-zero accuracy at thirty-six times fewer full-model calls.</a:t>
+              <a:t>Which model to scale? A bigger drafter, 3B, holds 0.80 accuracy at thirty-six times fewer calls, because it's accepted more. A bigger verifier, 32B, collapses to 0.33, because the weak drafter's tokens no longer match. The lever is the drafter.</a:t>
             </a:r>
           </a:p>
         </p:txBody>
@@ -868,7 +868,7 @@
           <a:lstStyle/>
           <a:p>
             <a:r>
-              <a:t>A stronger slim verifier, via DIMR, lifts accuracy from zero-point-eight-eight to zero-point-nine-one. Lambda exposes a full tunable frontier, up to ten times fewer calls.</a:t>
+              <a:t>Two more knobs. A better slim verifier via DIMR lifts REINFORCE from 0.88 to 0.91, but is moot once the gate is accept-heavy. And the honest negative: optimizing correctness directly degraded every policy, so the match-trained gate stays best.</a:t>
             </a:r>
           </a:p>
         </p:txBody>
@@ -938,7 +938,7 @@
           <a:lstStyle/>
           <a:p>
             <a:r>
-              <a:t>In summary: lossless zero-point-nine-one accuracy at four times fewer model calls. A tunable frontier reaching ten times fewer calls. A new state of the art that Pareto-dominates VIA-SD.</a:t>
+              <a:t>Impact: lossless accuracy at four times fewer calls with zero accuracy lost; a tunable frontier up to ten times fewer calls; and we Pareto-dominate VIA-SD at twice its speedup and higher accuracy. S4D is the new state of the art in hierarchical speculative decoding.</a:t>
             </a:r>
           </a:p>
         </p:txBody>
@@ -1008,7 +1008,7 @@
           <a:lstStyle/>
           <a:p>
             <a:r>
-              <a:t>Future work extends this to fully self-speculative decoding, where the drafter is itself a subset of the verifier. We also study KnapSpec, allocating a verifier budget like a knapsack across tokens.</a:t>
+              <a:t>Next: spec-spec decoding, making the drafter itself speculative; KnapSpec, spending a verifier budget like a knapsack on the highest-impact tokens; a correctness-floor objective; and real wall-clock at scale.</a:t>
             </a:r>
           </a:p>
         </p:txBody>
@@ -1078,7 +1078,7 @@
           <a:lstStyle/>
           <a:p>
             <a:r>
-              <a:t>To summarize: S-four-D turns hand-tuned thresholds into a learned policy, and sets the state of the art in hierarchical speculative decoding. Thank you.</a:t>
+              <a:t>To sum up: S4D turns hand-tuned thresholds into a learned policy and sets the state of the art in hierarchical speculative decoding. Thank you.</a:t>
             </a:r>
           </a:p>
         </p:txBody>
@@ -1148,7 +1148,7 @@
           <a:lstStyle/>
           <a:p>
             <a:r>
-              <a:t>Speculative decoding accelerates LLM inference. VIA-SD adds a slim middle verifier, but routes with hand-tuned thresholds. We make three contributions: a learned per-token gating policy, a quality-cost reward, and per-token reinforcement learning.</a:t>
+              <a:t>Speculative decoding speeds up LLMs. VIA-SD adds a slim middle verifier but routes with hand-tuned thresholds. Our three contributions: a learned per-token gate, a quality-versus-cost reward, and per-token RL. The payoff: lossless accuracy at four times fewer calls, up to three and a half times faster, a new state of the art.</a:t>
             </a:r>
           </a:p>
         </p:txBody>
@@ -1218,7 +1218,7 @@
           <a:lstStyle/>
           <a:p>
             <a:r>
-              <a:t>LLM decoding is memory-bandwidth bound and sequential. A small drafter proposes tokens; the verifier checks them in parallel. This is lossless and about one-point-four times faster. The key lever is the acceptance rate.</a:t>
+              <a:t>Each token streams the whole model from memory, so inference is slow. Speculative decoding lets a small drafter guess and the big model verify in parallel: lossless, about 1.4 times faster. The lever is the acceptance rate.</a:t>
             </a:r>
           </a:p>
         </p:txBody>
@@ -1288,7 +1288,7 @@
           <a:lstStyle/>
           <a:p>
             <a:r>
-              <a:t>VIA-SD adds a slim verifier, q-prime, the target with roughly half its layers skipped. This gives three choices: accept, regenerate, or escalate. Borderline tokens are handled cheaply, so the full model is called far less often.</a:t>
+              <a:t>VIA-SD adds a slim middle verifier, the target with half its layers skipped, giving three choices: accept, regenerate, or escalate. Borderline tokens go to the cheap tier. Because the model verifies its own draft through a reduced copy of itself, that is the Semi-Self in our name.</a:t>
             </a:r>
           </a:p>
         </p:txBody>
@@ -1358,7 +1358,7 @@
           <a:lstStyle/>
           <a:p>
             <a:r>
-              <a:t>VIA-SD routes with two fixed thresholds. They are global, brittle, and sub-optimal. Even after a full sweep, accuracy peaks at only zero-point-five-zero.</a:t>
+              <a:t>But VIA-SD picks between tiers with two hand-tuned thresholds, 0.5 and 0.3. They're global, brittle, and cap at 0.50 accuracy even fully swept, because one cutoff can't adapt to context. Routing per token is a decision problem, so the gate teaches itself: the Self-Taught.</a:t>
             </a:r>
           </a:p>
         </p:txBody>
@@ -1428,7 +1428,7 @@
           <a:lstStyle/>
           <a:p>
             <a:r>
-              <a:t>Our first contribution recasts routing as a sequential decision problem. A tiny, q-free MLP replaces the fixed thresholds. The full model is used only for training rewards, never to decide a route.</a:t>
+              <a:t>Contribution one: the learned gate, framed as an MDP. State is cheap q-free features, action is the tier, policy is a tiny MLP. The full model is used only for rewards at training time, never to decide, so the gate is free to deploy.</a:t>
             </a:r>
           </a:p>
         </p:txBody>
@@ -1498,7 +1498,7 @@
           <a:lstStyle/>
           <a:p>
             <a:r>
-              <a:t>Our second contribution is the reward: match minus lambda times cost. Match rewards agreement with the full model. Lambda is a single knob that trades accuracy for speed.</a:t>
+              <a:t>Contribution two: the reward, match minus lambda times cost. Quality is whether our token matches the full model; lambda trades accuracy for speed. One caveat: match is a proxy, and ninety-eight percent token match still gives only 0.72 final accuracy, because slips compound.</a:t>
             </a:r>
           </a:p>
         </p:txBody>
@@ -1568,7 +1568,7 @@
           <a:lstStyle/>
           <a:p>
             <a:r>
-              <a:t>Our third contribution is per-token reinforcement learning. We progress from REINFORCE to GRPO to a per-token advantage. This yields principled, low-variance credit assignment.</a:t>
+              <a:t>Contribution three: per-token RL. Same policy gradient; they differ only in the advantage. REINFORCE uses one noisy trajectory reward, GRPO normalizes within a group, and our per-token version gives each decision its own advantage: lowest variance, best results. Credit assignment is everything.</a:t>
             </a:r>
           </a:p>
         </p:txBody>
@@ -1638,7 +1638,7 @@
           <a:lstStyle/>
           <a:p>
             <a:r>
-              <a:t>All variants converge. Match reaches zero-point-nine-five and rejection falls steadily. The per-token formulation is the smoothest and lowest-variance.</a:t>
+              <a:t>All three converge, match reaches about 0.95, rejection falls, and per-token in blue is smoothest. Match plateaus at 0.95, not 1.0, and that residual is what compounds into the accuracy gap.</a:t>
             </a:r>
           </a:p>
         </p:txBody>
@@ -4646,7 +4646,7 @@
       <p:grpSpPr/>
       <p:pic>
         <p:nvPicPr>
-          <p:cNvPr id="2" name="Picture 1" descr="rn_00.png"/>
+          <p:cNvPr id="2" name="Picture 1" descr="pg_00.png"/>
           <p:cNvPicPr>
             <a:picLocks noChangeAspect="1"/>
           </p:cNvPicPr>
@@ -4688,7 +4688,7 @@
       <p:grpSpPr/>
       <p:pic>
         <p:nvPicPr>
-          <p:cNvPr id="2" name="Picture 1" descr="rn_09.png"/>
+          <p:cNvPr id="2" name="Picture 1" descr="pg_09.png"/>
           <p:cNvPicPr>
             <a:picLocks noChangeAspect="1"/>
           </p:cNvPicPr>
@@ -4730,7 +4730,7 @@
       <p:grpSpPr/>
       <p:pic>
         <p:nvPicPr>
-          <p:cNvPr id="2" name="Picture 1" descr="rn_10.png"/>
+          <p:cNvPr id="2" name="Picture 1" descr="pg_10.png"/>
           <p:cNvPicPr>
             <a:picLocks noChangeAspect="1"/>
           </p:cNvPicPr>
@@ -4772,7 +4772,7 @@
       <p:grpSpPr/>
       <p:pic>
         <p:nvPicPr>
-          <p:cNvPr id="2" name="Picture 1" descr="rn_11.png"/>
+          <p:cNvPr id="2" name="Picture 1" descr="pg_11.png"/>
           <p:cNvPicPr>
             <a:picLocks noChangeAspect="1"/>
           </p:cNvPicPr>
@@ -4814,7 +4814,7 @@
       <p:grpSpPr/>
       <p:pic>
         <p:nvPicPr>
-          <p:cNvPr id="2" name="Picture 1" descr="rn_12.png"/>
+          <p:cNvPr id="2" name="Picture 1" descr="pg_12.png"/>
           <p:cNvPicPr>
             <a:picLocks noChangeAspect="1"/>
           </p:cNvPicPr>
@@ -4856,7 +4856,7 @@
       <p:grpSpPr/>
       <p:pic>
         <p:nvPicPr>
-          <p:cNvPr id="2" name="Picture 1" descr="rn_13.png"/>
+          <p:cNvPr id="2" name="Picture 1" descr="pg_13.png"/>
           <p:cNvPicPr>
             <a:picLocks noChangeAspect="1"/>
           </p:cNvPicPr>
@@ -4898,7 +4898,7 @@
       <p:grpSpPr/>
       <p:pic>
         <p:nvPicPr>
-          <p:cNvPr id="2" name="Picture 1" descr="rn_14.png"/>
+          <p:cNvPr id="2" name="Picture 1" descr="pg_14.png"/>
           <p:cNvPicPr>
             <a:picLocks noChangeAspect="1"/>
           </p:cNvPicPr>
@@ -4940,7 +4940,7 @@
       <p:grpSpPr/>
       <p:pic>
         <p:nvPicPr>
-          <p:cNvPr id="2" name="Picture 1" descr="rn_15.png"/>
+          <p:cNvPr id="2" name="Picture 1" descr="pg_15.png"/>
           <p:cNvPicPr>
             <a:picLocks noChangeAspect="1"/>
           </p:cNvPicPr>
@@ -4982,7 +4982,7 @@
       <p:grpSpPr/>
       <p:pic>
         <p:nvPicPr>
-          <p:cNvPr id="2" name="Picture 1" descr="rn_16.png"/>
+          <p:cNvPr id="2" name="Picture 1" descr="pg_16.png"/>
           <p:cNvPicPr>
             <a:picLocks noChangeAspect="1"/>
           </p:cNvPicPr>
@@ -5024,7 +5024,7 @@
       <p:grpSpPr/>
       <p:pic>
         <p:nvPicPr>
-          <p:cNvPr id="2" name="Picture 1" descr="rn_01.png"/>
+          <p:cNvPr id="2" name="Picture 1" descr="pg_01.png"/>
           <p:cNvPicPr>
             <a:picLocks noChangeAspect="1"/>
           </p:cNvPicPr>
@@ -5066,7 +5066,7 @@
       <p:grpSpPr/>
       <p:pic>
         <p:nvPicPr>
-          <p:cNvPr id="2" name="Picture 1" descr="rn_02.png"/>
+          <p:cNvPr id="2" name="Picture 1" descr="pg_02.png"/>
           <p:cNvPicPr>
             <a:picLocks noChangeAspect="1"/>
           </p:cNvPicPr>
@@ -5108,7 +5108,7 @@
       <p:grpSpPr/>
       <p:pic>
         <p:nvPicPr>
-          <p:cNvPr id="2" name="Picture 1" descr="rn_03.png"/>
+          <p:cNvPr id="2" name="Picture 1" descr="pg_03.png"/>
           <p:cNvPicPr>
             <a:picLocks noChangeAspect="1"/>
           </p:cNvPicPr>
@@ -5150,7 +5150,7 @@
       <p:grpSpPr/>
       <p:pic>
         <p:nvPicPr>
-          <p:cNvPr id="2" name="Picture 1" descr="rn_04.png"/>
+          <p:cNvPr id="2" name="Picture 1" descr="pg_04.png"/>
           <p:cNvPicPr>
             <a:picLocks noChangeAspect="1"/>
           </p:cNvPicPr>
@@ -5192,7 +5192,7 @@
       <p:grpSpPr/>
       <p:pic>
         <p:nvPicPr>
-          <p:cNvPr id="2" name="Picture 1" descr="rn_05.png"/>
+          <p:cNvPr id="2" name="Picture 1" descr="pg_05.png"/>
           <p:cNvPicPr>
             <a:picLocks noChangeAspect="1"/>
           </p:cNvPicPr>
@@ -5234,7 +5234,7 @@
       <p:grpSpPr/>
       <p:pic>
         <p:nvPicPr>
-          <p:cNvPr id="2" name="Picture 1" descr="rn_06.png"/>
+          <p:cNvPr id="2" name="Picture 1" descr="pg_06.png"/>
           <p:cNvPicPr>
             <a:picLocks noChangeAspect="1"/>
           </p:cNvPicPr>
@@ -5276,7 +5276,7 @@
       <p:grpSpPr/>
       <p:pic>
         <p:nvPicPr>
-          <p:cNvPr id="2" name="Picture 1" descr="rn_07.png"/>
+          <p:cNvPr id="2" name="Picture 1" descr="pg_07.png"/>
           <p:cNvPicPr>
             <a:picLocks noChangeAspect="1"/>
           </p:cNvPicPr>
@@ -5318,7 +5318,7 @@
       <p:grpSpPr/>
       <p:pic>
         <p:nvPicPr>
-          <p:cNvPr id="2" name="Picture 1" descr="rn_08.png"/>
+          <p:cNvPr id="2" name="Picture 1" descr="pg_08.png"/>
           <p:cNvPicPr>
             <a:picLocks noChangeAspect="1"/>
           </p:cNvPicPr>

</xml_diff>